<commit_message>
chore: sync local state before force push
</commit_message>
<xml_diff>
--- a/A0_Poster/2026-03-09/A0_Final_Poster_revised.pptx
+++ b/A0_Poster/2026-03-09/A0_Final_Poster_revised.pptx
@@ -4534,8 +4534,8 @@
         </p:nvSpPr>
         <p:spPr>
           <a:xfrm>
-            <a:off x="15320772" y="5433365"/>
-            <a:ext cx="14497812" cy="2819095"/>
+            <a:off x="15320772" y="5577840"/>
+            <a:ext cx="14497812" cy="3291840"/>
           </a:xfrm>
           <a:prstGeom prst="rect">
             <a:avLst/>
@@ -4561,8 +4561,8 @@
         </p:nvSpPr>
         <p:spPr>
           <a:xfrm>
-            <a:off x="15320772" y="5433365"/>
-            <a:ext cx="14497812" cy="2819095"/>
+            <a:off x="15320772" y="5577840"/>
+            <a:ext cx="14497812" cy="3291840"/>
           </a:xfrm>
           <a:prstGeom prst="rect">
             <a:avLst/>
@@ -4655,7 +4655,7 @@
         </p:nvSpPr>
         <p:spPr>
           <a:xfrm>
-            <a:off x="15320772" y="8409737"/>
+            <a:off x="15320772" y="9052560"/>
             <a:ext cx="822960" cy="822960"/>
           </a:xfrm>
           <a:prstGeom prst="ellipse">
@@ -4675,7 +4675,7 @@
         </p:nvSpPr>
         <p:spPr>
           <a:xfrm>
-            <a:off x="15320772" y="8409737"/>
+            <a:off x="15320772" y="9052560"/>
             <a:ext cx="822960" cy="822960"/>
           </a:xfrm>
           <a:prstGeom prst="rect">
@@ -4714,7 +4714,7 @@
         </p:nvSpPr>
         <p:spPr>
           <a:xfrm>
-            <a:off x="16280892" y="8409737"/>
+            <a:off x="16280892" y="9052560"/>
             <a:ext cx="13537692" cy="822960"/>
           </a:xfrm>
           <a:prstGeom prst="rect">
@@ -4753,8 +4753,8 @@
         </p:nvSpPr>
         <p:spPr>
           <a:xfrm>
-            <a:off x="15320772" y="9271102"/>
-            <a:ext cx="14497812" cy="4385462"/>
+            <a:off x="15320772" y="10058400"/>
+            <a:ext cx="14497812" cy="5120640"/>
           </a:xfrm>
           <a:prstGeom prst="rect">
             <a:avLst/>
@@ -4780,8 +4780,8 @@
         </p:nvSpPr>
         <p:spPr>
           <a:xfrm>
-            <a:off x="15503652" y="9349740"/>
-            <a:ext cx="14132052" cy="391363"/>
+            <a:off x="15503652" y="10149840"/>
+            <a:ext cx="14132052" cy="457200"/>
           </a:xfrm>
           <a:prstGeom prst="rect">
             <a:avLst/>
@@ -4826,7 +4826,7 @@
           </p:nvPr>
         </p:nvGraphicFramePr>
         <p:xfrm>
-          <a:off x="15503652" y="9819742"/>
+          <a:off x="15503652" y="10698480"/>
           <a:ext cx="14132052" cy="914400"/>
         </p:xfrm>
         <a:graphic>
@@ -4838,7 +4838,7 @@
                 <a:gridCol w="6359423"/>
                 <a:gridCol w="5228859"/>
               </a:tblGrid>
-              <a:tr h="352044">
+              <a:tr h="411480">
                 <a:tc>
                   <a:txBody>
                     <a:bodyPr/>
@@ -5023,7 +5023,7 @@
                   </a:tcPr>
                 </a:tc>
               </a:tr>
-              <a:tr h="782726">
+              <a:tr h="914400">
                 <a:tc>
                   <a:txBody>
                     <a:bodyPr/>
@@ -5213,7 +5213,7 @@
                   </a:tcPr>
                 </a:tc>
               </a:tr>
-              <a:tr h="782726">
+              <a:tr h="914400">
                 <a:tc>
                   <a:txBody>
                     <a:bodyPr/>
@@ -5403,7 +5403,7 @@
                   </a:tcPr>
                 </a:tc>
               </a:tr>
-              <a:tr h="782726">
+              <a:tr h="914400">
                 <a:tc>
                   <a:txBody>
                     <a:bodyPr/>
@@ -5593,7 +5593,7 @@
                   </a:tcPr>
                 </a:tc>
               </a:tr>
-              <a:tr h="782726">
+              <a:tr h="914400">
                 <a:tc>
                   <a:txBody>
                     <a:bodyPr/>
@@ -5795,8 +5795,8 @@
         </p:nvSpPr>
         <p:spPr>
           <a:xfrm>
-            <a:off x="15503652" y="13030200"/>
-            <a:ext cx="14132052" cy="470002"/>
+            <a:off x="15503652" y="14447520"/>
+            <a:ext cx="14132052" cy="548640"/>
           </a:xfrm>
           <a:prstGeom prst="rect">
             <a:avLst/>
@@ -5834,7 +5834,7 @@
         </p:nvSpPr>
         <p:spPr>
           <a:xfrm>
-            <a:off x="15320772" y="13812926"/>
+            <a:off x="15320772" y="15361920"/>
             <a:ext cx="822960" cy="822960"/>
           </a:xfrm>
           <a:prstGeom prst="ellipse">
@@ -5854,7 +5854,7 @@
         </p:nvSpPr>
         <p:spPr>
           <a:xfrm>
-            <a:off x="15320772" y="13812926"/>
+            <a:off x="15320772" y="15361920"/>
             <a:ext cx="822960" cy="822960"/>
           </a:xfrm>
           <a:prstGeom prst="rect">
@@ -5893,7 +5893,7 @@
         </p:nvSpPr>
         <p:spPr>
           <a:xfrm>
-            <a:off x="16280892" y="13812926"/>
+            <a:off x="16280892" y="15361920"/>
             <a:ext cx="13537692" cy="822960"/>
           </a:xfrm>
           <a:prstGeom prst="rect">
@@ -5932,8 +5932,8 @@
         </p:nvSpPr>
         <p:spPr>
           <a:xfrm>
-            <a:off x="15320772" y="14674291"/>
-            <a:ext cx="14497812" cy="2192731"/>
+            <a:off x="15320772" y="16367760"/>
+            <a:ext cx="14497812" cy="2560320"/>
           </a:xfrm>
           <a:prstGeom prst="rect">
             <a:avLst/>
@@ -5959,8 +5959,8 @@
         </p:nvSpPr>
         <p:spPr>
           <a:xfrm>
-            <a:off x="15503652" y="14752930"/>
-            <a:ext cx="14132052" cy="391363"/>
+            <a:off x="15503652" y="16459200"/>
+            <a:ext cx="14132052" cy="457200"/>
           </a:xfrm>
           <a:prstGeom prst="rect">
             <a:avLst/>
@@ -6005,7 +6005,7 @@
           </p:nvPr>
         </p:nvGraphicFramePr>
         <p:xfrm>
-          <a:off x="15503652" y="15183612"/>
+          <a:off x="15503652" y="16962120"/>
           <a:ext cx="14132052" cy="914400"/>
         </p:xfrm>
         <a:graphic>
@@ -6016,7 +6016,7 @@
                 <a:gridCol w="3109051"/>
                 <a:gridCol w="11023001"/>
               </a:tblGrid>
-              <a:tr h="313639">
+              <a:tr h="365760">
                 <a:tc>
                   <a:txBody>
                     <a:bodyPr/>
@@ -6140,7 +6140,7 @@
                   </a:tcPr>
                 </a:tc>
               </a:tr>
-              <a:tr h="313639">
+              <a:tr h="365760">
                 <a:tc>
                   <a:txBody>
                     <a:bodyPr/>
@@ -6258,7 +6258,7 @@
                   </a:tcPr>
                 </a:tc>
               </a:tr>
-              <a:tr h="313639">
+              <a:tr h="365760">
                 <a:tc>
                   <a:txBody>
                     <a:bodyPr/>
@@ -6376,7 +6376,7 @@
                   </a:tcPr>
                 </a:tc>
               </a:tr>
-              <a:tr h="313639">
+              <a:tr h="365760">
                 <a:tc>
                   <a:txBody>
                     <a:bodyPr/>
@@ -6494,7 +6494,7 @@
                   </a:tcPr>
                 </a:tc>
               </a:tr>
-              <a:tr h="313639">
+              <a:tr h="365760">
                 <a:tc>
                   <a:txBody>
                     <a:bodyPr/>
@@ -6612,7 +6612,7 @@
                   </a:tcPr>
                 </a:tc>
               </a:tr>
-              <a:tr h="313639">
+              <a:tr h="365760">
                 <a:tc>
                   <a:txBody>
                     <a:bodyPr/>
@@ -6730,7 +6730,7 @@
                   </a:tcPr>
                 </a:tc>
               </a:tr>
-              <a:tr h="274320">
+              <a:tr h="320040">
                 <a:tc>
                   <a:txBody>
                     <a:bodyPr/>
@@ -6860,8 +6860,8 @@
         </p:nvSpPr>
         <p:spPr>
           <a:xfrm>
-            <a:off x="15320772" y="17493386"/>
-            <a:ext cx="14497812" cy="4306824"/>
+            <a:off x="15320772" y="19659600"/>
+            <a:ext cx="14497812" cy="5029200"/>
           </a:xfrm>
           <a:prstGeom prst="rect">
             <a:avLst/>
@@ -6887,8 +6887,8 @@
         </p:nvSpPr>
         <p:spPr>
           <a:xfrm>
-            <a:off x="15503652" y="17572025"/>
-            <a:ext cx="14132052" cy="391363"/>
+            <a:off x="15503652" y="19751040"/>
+            <a:ext cx="14132052" cy="457200"/>
           </a:xfrm>
           <a:prstGeom prst="rect">
             <a:avLst/>
@@ -6933,7 +6933,7 @@
           </p:nvPr>
         </p:nvGraphicFramePr>
         <p:xfrm>
-          <a:off x="15503652" y="18002707"/>
+          <a:off x="15503652" y="20253960"/>
           <a:ext cx="14132052" cy="914400"/>
         </p:xfrm>
         <a:graphic>
@@ -6945,7 +6945,7 @@
                 <a:gridCol w="5652821"/>
                 <a:gridCol w="5652821"/>
               </a:tblGrid>
-              <a:tr h="470002">
+              <a:tr h="548640">
                 <a:tc>
                   <a:txBody>
                     <a:bodyPr/>
@@ -7158,7 +7158,7 @@
                   </a:tcPr>
                 </a:tc>
               </a:tr>
-              <a:tr h="430682">
+              <a:tr h="502920">
                 <a:tc>
                   <a:txBody>
                     <a:bodyPr/>
@@ -7334,7 +7334,7 @@
                   </a:tcPr>
                 </a:tc>
               </a:tr>
-              <a:tr h="430682">
+              <a:tr h="502920">
                 <a:tc>
                   <a:txBody>
                     <a:bodyPr/>
@@ -7510,7 +7510,7 @@
                   </a:tcPr>
                 </a:tc>
               </a:tr>
-              <a:tr h="430682">
+              <a:tr h="502920">
                 <a:tc>
                   <a:txBody>
                     <a:bodyPr/>
@@ -7686,7 +7686,7 @@
                   </a:tcPr>
                 </a:tc>
               </a:tr>
-              <a:tr h="430682">
+              <a:tr h="502920">
                 <a:tc>
                   <a:txBody>
                     <a:bodyPr/>
@@ -7874,8 +7874,8 @@
         </p:nvSpPr>
         <p:spPr>
           <a:xfrm>
-            <a:off x="15503652" y="20234758"/>
-            <a:ext cx="14132052" cy="1175004"/>
+            <a:off x="15503652" y="22860000"/>
+            <a:ext cx="14132052" cy="1371600"/>
           </a:xfrm>
           <a:prstGeom prst="rect">
             <a:avLst/>
@@ -7969,8 +7969,8 @@
         </p:nvSpPr>
         <p:spPr>
           <a:xfrm>
-            <a:off x="15503652" y="21408847"/>
-            <a:ext cx="14132052" cy="626364"/>
+            <a:off x="15503652" y="24231600"/>
+            <a:ext cx="14132052" cy="731520"/>
           </a:xfrm>
           <a:prstGeom prst="rect">
             <a:avLst/>
@@ -8022,8 +8022,8 @@
         </p:nvSpPr>
         <p:spPr>
           <a:xfrm>
-            <a:off x="15320772" y="22192488"/>
-            <a:ext cx="14497812" cy="2819095"/>
+            <a:off x="15320772" y="25146000"/>
+            <a:ext cx="14497812" cy="3291840"/>
           </a:xfrm>
           <a:prstGeom prst="rect">
             <a:avLst/>
@@ -8049,8 +8049,8 @@
         </p:nvSpPr>
         <p:spPr>
           <a:xfrm>
-            <a:off x="15503652" y="22271126"/>
-            <a:ext cx="14132052" cy="391363"/>
+            <a:off x="15503652" y="25237440"/>
+            <a:ext cx="14132052" cy="457200"/>
           </a:xfrm>
           <a:prstGeom prst="rect">
             <a:avLst/>
@@ -8095,7 +8095,7 @@
           </p:nvPr>
         </p:nvGraphicFramePr>
         <p:xfrm>
-          <a:off x="15503652" y="22701809"/>
+          <a:off x="15503652" y="25740360"/>
           <a:ext cx="14132052" cy="914400"/>
         </p:xfrm>
         <a:graphic>
@@ -8107,7 +8107,7 @@
                 <a:gridCol w="5652821"/>
                 <a:gridCol w="5370180"/>
               </a:tblGrid>
-              <a:tr h="313639">
+              <a:tr h="365760">
                 <a:tc>
                   <a:txBody>
                     <a:bodyPr/>
@@ -8292,7 +8292,7 @@
                   </a:tcPr>
                 </a:tc>
               </a:tr>
-              <a:tr h="509321">
+              <a:tr h="594360">
                 <a:tc>
                   <a:txBody>
                     <a:bodyPr/>
@@ -8496,7 +8496,7 @@
                   </a:tcPr>
                 </a:tc>
               </a:tr>
-              <a:tr h="509321">
+              <a:tr h="594360">
                 <a:tc>
                   <a:txBody>
                     <a:bodyPr/>
@@ -8700,7 +8700,7 @@
                   </a:tcPr>
                 </a:tc>
               </a:tr>
-              <a:tr h="509321">
+              <a:tr h="594360">
                 <a:tc>
                   <a:txBody>
                     <a:bodyPr/>
@@ -8916,8 +8916,8 @@
         </p:nvSpPr>
         <p:spPr>
           <a:xfrm>
-            <a:off x="15320772" y="25168860"/>
-            <a:ext cx="14497812" cy="2036369"/>
+            <a:off x="15320772" y="28620720"/>
+            <a:ext cx="14497812" cy="2377440"/>
           </a:xfrm>
           <a:prstGeom prst="rect">
             <a:avLst/>
@@ -8943,8 +8943,8 @@
         </p:nvSpPr>
         <p:spPr>
           <a:xfrm>
-            <a:off x="15503652" y="25247498"/>
-            <a:ext cx="14132052" cy="391363"/>
+            <a:off x="15503652" y="28712160"/>
+            <a:ext cx="14132052" cy="457200"/>
           </a:xfrm>
           <a:prstGeom prst="rect">
             <a:avLst/>
@@ -8982,8 +8982,8 @@
         </p:nvSpPr>
         <p:spPr>
           <a:xfrm>
-            <a:off x="15503652" y="25678181"/>
-            <a:ext cx="14132052" cy="1410005"/>
+            <a:off x="15503652" y="29215080"/>
+            <a:ext cx="14132052" cy="1645920"/>
           </a:xfrm>
           <a:prstGeom prst="rect">
             <a:avLst/>
@@ -9072,8 +9072,8 @@
         </p:nvSpPr>
         <p:spPr>
           <a:xfrm>
-            <a:off x="15320772" y="27361591"/>
-            <a:ext cx="14497812" cy="2036369"/>
+            <a:off x="15320772" y="31181040"/>
+            <a:ext cx="14497812" cy="2377440"/>
           </a:xfrm>
           <a:prstGeom prst="rect">
             <a:avLst/>
@@ -9099,8 +9099,8 @@
         </p:nvSpPr>
         <p:spPr>
           <a:xfrm>
-            <a:off x="15503652" y="27440230"/>
-            <a:ext cx="14132052" cy="352044"/>
+            <a:off x="15503652" y="31272480"/>
+            <a:ext cx="14132052" cy="411480"/>
           </a:xfrm>
           <a:prstGeom prst="rect">
             <a:avLst/>
@@ -9138,8 +9138,8 @@
         </p:nvSpPr>
         <p:spPr>
           <a:xfrm>
-            <a:off x="15503652" y="27792274"/>
-            <a:ext cx="14132052" cy="1487729"/>
+            <a:off x="15503652" y="31683960"/>
+            <a:ext cx="14132052" cy="1737360"/>
           </a:xfrm>
           <a:prstGeom prst="rect">
             <a:avLst/>
@@ -9234,7 +9234,7 @@
         </p:nvSpPr>
         <p:spPr>
           <a:xfrm>
-            <a:off x="457200" y="37179504"/>
+            <a:off x="457200" y="34015680"/>
             <a:ext cx="29361384" cy="4572000"/>
           </a:xfrm>
           <a:prstGeom prst="rect">
@@ -9261,7 +9261,7 @@
         </p:nvSpPr>
         <p:spPr>
           <a:xfrm>
-            <a:off x="731520" y="37362384"/>
+            <a:off x="731520" y="34198560"/>
             <a:ext cx="822960" cy="822960"/>
           </a:xfrm>
           <a:prstGeom prst="ellipse">
@@ -9281,7 +9281,7 @@
         </p:nvSpPr>
         <p:spPr>
           <a:xfrm>
-            <a:off x="731520" y="37362384"/>
+            <a:off x="731520" y="34198560"/>
             <a:ext cx="822960" cy="822960"/>
           </a:xfrm>
           <a:prstGeom prst="rect">
@@ -9320,7 +9320,7 @@
         </p:nvSpPr>
         <p:spPr>
           <a:xfrm>
-            <a:off x="1691640" y="37362384"/>
+            <a:off x="1691640" y="34198560"/>
             <a:ext cx="27852624" cy="822960"/>
           </a:xfrm>
           <a:prstGeom prst="rect">
@@ -9359,7 +9359,7 @@
         </p:nvSpPr>
         <p:spPr>
           <a:xfrm>
-            <a:off x="731520" y="38459664"/>
+            <a:off x="731520" y="35295840"/>
             <a:ext cx="9421368" cy="2926080"/>
           </a:xfrm>
           <a:prstGeom prst="rect">
@@ -9386,7 +9386,7 @@
         </p:nvSpPr>
         <p:spPr>
           <a:xfrm>
-            <a:off x="731520" y="38459664"/>
+            <a:off x="731520" y="35295840"/>
             <a:ext cx="9421368" cy="73152"/>
           </a:xfrm>
           <a:prstGeom prst="rect">
@@ -9406,7 +9406,7 @@
         </p:nvSpPr>
         <p:spPr>
           <a:xfrm>
-            <a:off x="914400" y="38642544"/>
+            <a:off x="914400" y="35478720"/>
             <a:ext cx="457200" cy="457200"/>
           </a:xfrm>
           <a:prstGeom prst="rect">
@@ -9442,7 +9442,7 @@
         </p:nvSpPr>
         <p:spPr>
           <a:xfrm>
-            <a:off x="1463040" y="38642544"/>
+            <a:off x="1463040" y="35478720"/>
             <a:ext cx="8506968" cy="548640"/>
           </a:xfrm>
           <a:prstGeom prst="rect">
@@ -9481,7 +9481,7 @@
         </p:nvSpPr>
         <p:spPr>
           <a:xfrm>
-            <a:off x="1005840" y="39282624"/>
+            <a:off x="1005840" y="36118800"/>
             <a:ext cx="8872728" cy="1920240"/>
           </a:xfrm>
           <a:prstGeom prst="rect">
@@ -9520,7 +9520,7 @@
         </p:nvSpPr>
         <p:spPr>
           <a:xfrm>
-            <a:off x="10427208" y="38459664"/>
+            <a:off x="10427208" y="35295840"/>
             <a:ext cx="9421368" cy="2926080"/>
           </a:xfrm>
           <a:prstGeom prst="rect">
@@ -9547,7 +9547,7 @@
         </p:nvSpPr>
         <p:spPr>
           <a:xfrm>
-            <a:off x="10427208" y="38459664"/>
+            <a:off x="10427208" y="35295840"/>
             <a:ext cx="9421368" cy="73152"/>
           </a:xfrm>
           <a:prstGeom prst="rect">
@@ -9567,7 +9567,7 @@
         </p:nvSpPr>
         <p:spPr>
           <a:xfrm>
-            <a:off x="10610088" y="38642544"/>
+            <a:off x="10610088" y="35478720"/>
             <a:ext cx="457200" cy="457200"/>
           </a:xfrm>
           <a:prstGeom prst="rect">
@@ -9603,7 +9603,7 @@
         </p:nvSpPr>
         <p:spPr>
           <a:xfrm>
-            <a:off x="11158728" y="38642544"/>
+            <a:off x="11158728" y="35478720"/>
             <a:ext cx="8506968" cy="548640"/>
           </a:xfrm>
           <a:prstGeom prst="rect">
@@ -9642,7 +9642,7 @@
         </p:nvSpPr>
         <p:spPr>
           <a:xfrm>
-            <a:off x="10701528" y="39282624"/>
+            <a:off x="10701528" y="36118800"/>
             <a:ext cx="8872728" cy="1920240"/>
           </a:xfrm>
           <a:prstGeom prst="rect">
@@ -9681,7 +9681,7 @@
         </p:nvSpPr>
         <p:spPr>
           <a:xfrm>
-            <a:off x="20122896" y="38459664"/>
+            <a:off x="20122896" y="35295840"/>
             <a:ext cx="9421368" cy="2926080"/>
           </a:xfrm>
           <a:prstGeom prst="rect">
@@ -9708,7 +9708,7 @@
         </p:nvSpPr>
         <p:spPr>
           <a:xfrm>
-            <a:off x="20122896" y="38459664"/>
+            <a:off x="20122896" y="35295840"/>
             <a:ext cx="9421368" cy="73152"/>
           </a:xfrm>
           <a:prstGeom prst="rect">
@@ -9728,7 +9728,7 @@
         </p:nvSpPr>
         <p:spPr>
           <a:xfrm>
-            <a:off x="20305776" y="38642544"/>
+            <a:off x="20305776" y="35478720"/>
             <a:ext cx="457200" cy="457200"/>
           </a:xfrm>
           <a:prstGeom prst="rect">
@@ -9764,7 +9764,7 @@
         </p:nvSpPr>
         <p:spPr>
           <a:xfrm>
-            <a:off x="20854416" y="38642544"/>
+            <a:off x="20854416" y="35478720"/>
             <a:ext cx="8506968" cy="548640"/>
           </a:xfrm>
           <a:prstGeom prst="rect">
@@ -9803,7 +9803,7 @@
         </p:nvSpPr>
         <p:spPr>
           <a:xfrm>
-            <a:off x="20397216" y="39282624"/>
+            <a:off x="20397216" y="36118800"/>
             <a:ext cx="8872728" cy="1920240"/>
           </a:xfrm>
           <a:prstGeom prst="rect">

</xml_diff>